<commit_message>
added downsampling example for Lecture 13
</commit_message>
<xml_diff>
--- a/lecture_slides/Week8_Lecture13_Downsampling_Decimation_CNN_Strides_102026_forClass.pptx
+++ b/lecture_slides/Week8_Lecture13_Downsampling_Decimation_CNN_Strides_102026_forClass.pptx
@@ -5,7 +5,7 @@
     <p:sldMasterId id="2147483648" r:id="rId1"/>
   </p:sldMasterIdLst>
   <p:notesMasterIdLst>
-    <p:notesMasterId r:id="rId22"/>
+    <p:notesMasterId r:id="rId23"/>
   </p:notesMasterIdLst>
   <p:sldIdLst>
     <p:sldId id="294" r:id="rId2"/>
@@ -25,9 +25,10 @@
     <p:sldId id="269" r:id="rId16"/>
     <p:sldId id="270" r:id="rId17"/>
     <p:sldId id="271" r:id="rId18"/>
-    <p:sldId id="272" r:id="rId19"/>
-    <p:sldId id="273" r:id="rId20"/>
-    <p:sldId id="274" r:id="rId21"/>
+    <p:sldId id="295" r:id="rId19"/>
+    <p:sldId id="272" r:id="rId20"/>
+    <p:sldId id="273" r:id="rId21"/>
+    <p:sldId id="274" r:id="rId22"/>
   </p:sldIdLst>
   <p:sldSz cx="12192000" cy="6858000"/>
   <p:notesSz cx="6858000" cy="12192000"/>
@@ -1020,7 +1021,7 @@
           <a:p>
             <a:fld id="{F7021451-1387-4CA6-816F-3879F97B5CBC}" type="slidenum">
               <a:rPr lang="en-US"/>
-              <a:t>18</a:t>
+              <a:t>19</a:t>
             </a:fld>
             <a:endParaRPr lang="en-US"/>
           </a:p>
@@ -1107,7 +1108,7 @@
           <a:p>
             <a:fld id="{F7021451-1387-4CA6-816F-3879F97B5CBC}" type="slidenum">
               <a:rPr lang="en-US"/>
-              <a:t>19</a:t>
+              <a:t>20</a:t>
             </a:fld>
             <a:endParaRPr lang="en-US"/>
           </a:p>
@@ -1194,7 +1195,7 @@
           <a:p>
             <a:fld id="{F7021451-1387-4CA6-816F-3879F97B5CBC}" type="slidenum">
               <a:rPr lang="en-US"/>
-              <a:t>20</a:t>
+              <a:t>21</a:t>
             </a:fld>
             <a:endParaRPr lang="en-US"/>
           </a:p>
@@ -2094,7 +2095,7 @@
           </a:prstGeom>
           <a:extLst>
             <a:ext uri="{C572A759-6A51-4108-AA02-DFA0A04FC94B}">
-              <ma14:wrappingTextBoxFlag xmlns:ma14="http://schemas.microsoft.com/office/mac/drawingml/2011/main" xmlns="" val="0"/>
+              <ma14:wrappingTextBoxFlag xmlns="" xmlns:ma14="http://schemas.microsoft.com/office/mac/drawingml/2011/main" val="0"/>
             </a:ext>
           </a:extLst>
         </p:spPr>
@@ -2172,7 +2173,7 @@
           </a:prstGeom>
           <a:extLst>
             <a:ext uri="{C572A759-6A51-4108-AA02-DFA0A04FC94B}">
-              <ma14:wrappingTextBoxFlag xmlns:ma14="http://schemas.microsoft.com/office/mac/drawingml/2011/main" xmlns="" val="0"/>
+              <ma14:wrappingTextBoxFlag xmlns="" xmlns:ma14="http://schemas.microsoft.com/office/mac/drawingml/2011/main" val="0"/>
             </a:ext>
           </a:extLst>
         </p:spPr>
@@ -3491,7 +3492,7 @@
           </a:prstGeom>
           <a:extLst>
             <a:ext uri="{C572A759-6A51-4108-AA02-DFA0A04FC94B}">
-              <ma14:wrappingTextBoxFlag xmlns:ma14="http://schemas.microsoft.com/office/mac/drawingml/2011/main" xmlns="" val="0"/>
+              <ma14:wrappingTextBoxFlag xmlns="" xmlns:ma14="http://schemas.microsoft.com/office/mac/drawingml/2011/main" val="0"/>
             </a:ext>
           </a:extLst>
         </p:spPr>
@@ -3910,7 +3911,7 @@
           </a:prstGeom>
           <a:extLst>
             <a:ext uri="{C572A759-6A51-4108-AA02-DFA0A04FC94B}">
-              <ma14:wrappingTextBoxFlag xmlns:ma14="http://schemas.microsoft.com/office/mac/drawingml/2011/main" xmlns="" val="0"/>
+              <ma14:wrappingTextBoxFlag xmlns="" xmlns:ma14="http://schemas.microsoft.com/office/mac/drawingml/2011/main" val="0"/>
             </a:ext>
           </a:extLst>
         </p:spPr>
@@ -4588,7 +4589,7 @@
           </a:prstGeom>
           <a:extLst>
             <a:ext uri="{C572A759-6A51-4108-AA02-DFA0A04FC94B}">
-              <ma14:wrappingTextBoxFlag xmlns:ma14="http://schemas.microsoft.com/office/mac/drawingml/2011/main" xmlns="" val="0"/>
+              <ma14:wrappingTextBoxFlag xmlns="" xmlns:ma14="http://schemas.microsoft.com/office/mac/drawingml/2011/main" val="0"/>
             </a:ext>
           </a:extLst>
         </p:spPr>
@@ -4885,7 +4886,7 @@
           </a:prstGeom>
           <a:extLst>
             <a:ext uri="{C572A759-6A51-4108-AA02-DFA0A04FC94B}">
-              <ma14:wrappingTextBoxFlag xmlns:ma14="http://schemas.microsoft.com/office/mac/drawingml/2011/main" xmlns="" val="0"/>
+              <ma14:wrappingTextBoxFlag xmlns="" xmlns:ma14="http://schemas.microsoft.com/office/mac/drawingml/2011/main" val="0"/>
             </a:ext>
           </a:extLst>
         </p:spPr>
@@ -5799,7 +5800,7 @@
           </a:prstGeom>
           <a:extLst>
             <a:ext uri="{C572A759-6A51-4108-AA02-DFA0A04FC94B}">
-              <ma14:wrappingTextBoxFlag xmlns:ma14="http://schemas.microsoft.com/office/mac/drawingml/2011/main" xmlns="" val="0"/>
+              <ma14:wrappingTextBoxFlag xmlns="" xmlns:ma14="http://schemas.microsoft.com/office/mac/drawingml/2011/main" val="0"/>
             </a:ext>
           </a:extLst>
         </p:spPr>
@@ -6262,7 +6263,7 @@
           </a:prstGeom>
           <a:extLst>
             <a:ext uri="{C572A759-6A51-4108-AA02-DFA0A04FC94B}">
-              <ma14:wrappingTextBoxFlag xmlns:ma14="http://schemas.microsoft.com/office/mac/drawingml/2011/main" xmlns="" val="0"/>
+              <ma14:wrappingTextBoxFlag xmlns="" xmlns:ma14="http://schemas.microsoft.com/office/mac/drawingml/2011/main" val="0"/>
             </a:ext>
           </a:extLst>
         </p:spPr>
@@ -6918,7 +6919,7 @@
           </a:prstGeom>
           <a:extLst>
             <a:ext uri="{C572A759-6A51-4108-AA02-DFA0A04FC94B}">
-              <ma14:wrappingTextBoxFlag xmlns:ma14="http://schemas.microsoft.com/office/mac/drawingml/2011/main" xmlns="" val="0"/>
+              <ma14:wrappingTextBoxFlag xmlns="" xmlns:ma14="http://schemas.microsoft.com/office/mac/drawingml/2011/main" val="0"/>
             </a:ext>
           </a:extLst>
         </p:spPr>
@@ -6955,6 +6956,112 @@
 </file>
 
 <file path=ppt/slides/slide18.xml><?xml version="1.0" encoding="utf-8"?>
+<p:sld xmlns:a="http://schemas.openxmlformats.org/drawingml/2006/main" xmlns:r="http://schemas.openxmlformats.org/officeDocument/2006/relationships" xmlns:p="http://schemas.openxmlformats.org/presentationml/2006/main">
+  <p:cSld>
+    <p:spTree>
+      <p:nvGrpSpPr>
+        <p:cNvPr id="1" name=""/>
+        <p:cNvGrpSpPr/>
+        <p:nvPr/>
+      </p:nvGrpSpPr>
+      <p:grpSpPr>
+        <a:xfrm>
+          <a:off x="0" y="0"/>
+          <a:ext cx="0" cy="0"/>
+          <a:chOff x="0" y="0"/>
+          <a:chExt cx="0" cy="0"/>
+        </a:xfrm>
+      </p:grpSpPr>
+      <p:sp>
+        <p:nvSpPr>
+          <p:cNvPr id="2" name="TextBox 1">
+            <a:extLst>
+              <a:ext uri="{FF2B5EF4-FFF2-40B4-BE49-F238E27FC236}">
+                <a16:creationId xmlns:a16="http://schemas.microsoft.com/office/drawing/2014/main" id="{CC11E6C7-CDDB-F2B7-1962-2A6001D3D069}"/>
+              </a:ext>
+            </a:extLst>
+          </p:cNvPr>
+          <p:cNvSpPr txBox="1"/>
+          <p:nvPr/>
+        </p:nvSpPr>
+        <p:spPr>
+          <a:xfrm>
+            <a:off x="415637" y="576696"/>
+            <a:ext cx="5474447" cy="523220"/>
+          </a:xfrm>
+          <a:prstGeom prst="rect">
+            <a:avLst/>
+          </a:prstGeom>
+          <a:noFill/>
+        </p:spPr>
+        <p:txBody>
+          <a:bodyPr wrap="none" rtlCol="0">
+            <a:spAutoFit/>
+          </a:bodyPr>
+          <a:lstStyle/>
+          <a:p>
+            <a:r>
+              <a:rPr lang="en-US" sz="2800" b="1" dirty="0"/>
+              <a:t>CNN for Classifying Digit Images</a:t>
+            </a:r>
+          </a:p>
+        </p:txBody>
+      </p:sp>
+      <p:pic>
+        <p:nvPicPr>
+          <p:cNvPr id="3" name="Picture 2" descr="convnet">
+            <a:extLst>
+              <a:ext uri="{FF2B5EF4-FFF2-40B4-BE49-F238E27FC236}">
+                <a16:creationId xmlns:a16="http://schemas.microsoft.com/office/drawing/2014/main" id="{75A98794-541E-605D-6880-B2F4E08E9FF6}"/>
+              </a:ext>
+            </a:extLst>
+          </p:cNvPr>
+          <p:cNvPicPr>
+            <a:picLocks noChangeAspect="1"/>
+          </p:cNvPicPr>
+          <p:nvPr/>
+        </p:nvPicPr>
+        <p:blipFill>
+          <a:blip r:embed="rId2">
+            <a:extLst>
+              <a:ext uri="{28A0092B-C50C-407E-A947-70E740481C1C}">
+                <a14:useLocalDpi xmlns:a14="http://schemas.microsoft.com/office/drawing/2010/main" val="0"/>
+              </a:ext>
+            </a:extLst>
+          </a:blip>
+          <a:srcRect/>
+          <a:stretch>
+            <a:fillRect/>
+          </a:stretch>
+        </p:blipFill>
+        <p:spPr bwMode="auto">
+          <a:xfrm>
+            <a:off x="1441135" y="1917124"/>
+            <a:ext cx="8463133" cy="2330074"/>
+          </a:xfrm>
+          <a:prstGeom prst="rect">
+            <a:avLst/>
+          </a:prstGeom>
+          <a:noFill/>
+          <a:ln>
+            <a:noFill/>
+          </a:ln>
+        </p:spPr>
+      </p:pic>
+    </p:spTree>
+    <p:extLst>
+      <p:ext uri="{BB962C8B-B14F-4D97-AF65-F5344CB8AC3E}">
+        <p14:creationId xmlns:p14="http://schemas.microsoft.com/office/powerpoint/2010/main" val="3613948728"/>
+      </p:ext>
+    </p:extLst>
+  </p:cSld>
+  <p:clrMapOvr>
+    <a:masterClrMapping/>
+  </p:clrMapOvr>
+</p:sld>
+</file>
+
+<file path=ppt/slides/slide19.xml><?xml version="1.0" encoding="utf-8"?>
 <p:sld xmlns:a="http://schemas.openxmlformats.org/drawingml/2006/main" xmlns:r="http://schemas.openxmlformats.org/officeDocument/2006/relationships" xmlns:p="http://schemas.openxmlformats.org/presentationml/2006/main">
   <p:cSld name="Slide 17">
     <p:spTree>
@@ -7635,601 +7742,7 @@
           </a:prstGeom>
           <a:extLst>
             <a:ext uri="{C572A759-6A51-4108-AA02-DFA0A04FC94B}">
-              <ma14:wrappingTextBoxFlag xmlns:ma14="http://schemas.microsoft.com/office/mac/drawingml/2011/main" xmlns="" val="0"/>
-            </a:ext>
-          </a:extLst>
-        </p:spPr>
-        <p:txBody>
-          <a:bodyPr/>
-          <a:lstStyle>
-            <a:lvl1pPr>
-              <a:defRPr sz="850">
-                <a:solidFill>
-                  <a:srgbClr val="5B677A"/>
-                </a:solidFill>
-                <a:latin typeface="Aptos"/>
-                <a:ea typeface="Aptos"/>
-                <a:cs typeface="Aptos"/>
-              </a:defRPr>
-            </a:lvl1pPr>
-          </a:lstStyle>
-          <a:p>
-            <a:pPr algn="r"/>
-            <a:fld id="{F7021451-1387-4CA6-816F-3879F97B5CBC}" type="slidenum">
-              <a:rPr lang="en-US" b="0"/>
-              <a:t>18</a:t>
-            </a:fld>
-            <a:endParaRPr lang="en-US"/>
-          </a:p>
-        </p:txBody>
-      </p:sp>
-    </p:spTree>
-  </p:cSld>
-  <p:clrMapOvr>
-    <a:masterClrMapping/>
-  </p:clrMapOvr>
-</p:sld>
-</file>
-
-<file path=ppt/slides/slide19.xml><?xml version="1.0" encoding="utf-8"?>
-<p:sld xmlns:a="http://schemas.openxmlformats.org/drawingml/2006/main" xmlns:r="http://schemas.openxmlformats.org/officeDocument/2006/relationships" xmlns:p="http://schemas.openxmlformats.org/presentationml/2006/main">
-  <p:cSld name="Slide 18">
-    <p:spTree>
-      <p:nvGrpSpPr>
-        <p:cNvPr id="1" name=""/>
-        <p:cNvGrpSpPr/>
-        <p:nvPr/>
-      </p:nvGrpSpPr>
-      <p:grpSpPr>
-        <a:xfrm>
-          <a:off x="0" y="0"/>
-          <a:ext cx="0" cy="0"/>
-          <a:chOff x="0" y="0"/>
-          <a:chExt cx="0" cy="0"/>
-        </a:xfrm>
-      </p:grpSpPr>
-      <p:sp>
-        <p:nvSpPr>
-          <p:cNvPr id="2" name="Text 0"/>
-          <p:cNvSpPr/>
-          <p:nvPr/>
-        </p:nvSpPr>
-        <p:spPr>
-          <a:xfrm>
-            <a:off x="530352" y="347472"/>
-            <a:ext cx="2743200" cy="228600"/>
-          </a:xfrm>
-          <a:prstGeom prst="rect">
-            <a:avLst/>
-          </a:prstGeom>
-          <a:noFill/>
-          <a:ln/>
-        </p:spPr>
-        <p:txBody>
-          <a:bodyPr wrap="square" lIns="0" tIns="0" rIns="0" bIns="0" rtlCol="0" anchor="ctr"/>
-          <a:lstStyle/>
-          <a:p>
-            <a:pPr marL="0" indent="0">
-              <a:buNone/>
-            </a:pPr>
-            <a:r>
-              <a:rPr lang="en-US" sz="1000" b="1" dirty="0">
-                <a:solidFill>
-                  <a:srgbClr val="2F80A6"/>
-                </a:solidFill>
-                <a:latin typeface="Aptos" pitchFamily="34" charset="0"/>
-                <a:ea typeface="Aptos" pitchFamily="34" charset="-122"/>
-                <a:cs typeface="Aptos" pitchFamily="34" charset="-120"/>
-              </a:rPr>
-              <a:t>1:14–1:15</a:t>
-            </a:r>
-            <a:endParaRPr lang="en-US" sz="1000" dirty="0"/>
-          </a:p>
-        </p:txBody>
-      </p:sp>
-      <p:sp>
-        <p:nvSpPr>
-          <p:cNvPr id="3" name="Text 1"/>
-          <p:cNvSpPr/>
-          <p:nvPr/>
-        </p:nvSpPr>
-        <p:spPr>
-          <a:xfrm>
-            <a:off x="530352" y="621792"/>
-            <a:ext cx="11018520" cy="566928"/>
-          </a:xfrm>
-          <a:prstGeom prst="rect">
-            <a:avLst/>
-          </a:prstGeom>
-          <a:noFill/>
-          <a:ln/>
-        </p:spPr>
-        <p:txBody>
-          <a:bodyPr wrap="square" lIns="0" tIns="0" rIns="0" bIns="0" rtlCol="0" anchor="ctr">
-            <a:normAutofit/>
-          </a:bodyPr>
-          <a:lstStyle/>
-          <a:p>
-            <a:pPr marL="0" indent="0">
-              <a:buNone/>
-            </a:pPr>
-            <a:r>
-              <a:rPr lang="en-US" sz="2550" b="1" dirty="0">
-                <a:solidFill>
-                  <a:srgbClr val="16324F"/>
-                </a:solidFill>
-                <a:latin typeface="Aptos" pitchFamily="34" charset="0"/>
-                <a:ea typeface="Aptos" pitchFamily="34" charset="-122"/>
-                <a:cs typeface="Aptos" pitchFamily="34" charset="-120"/>
-              </a:rPr>
-              <a:t>Lecture 13 wrap-up</a:t>
-            </a:r>
-            <a:endParaRPr lang="en-US" sz="2550" dirty="0"/>
-          </a:p>
-        </p:txBody>
-      </p:sp>
-      <p:sp>
-        <p:nvSpPr>
-          <p:cNvPr id="4" name="Text 2"/>
-          <p:cNvSpPr/>
-          <p:nvPr/>
-        </p:nvSpPr>
-        <p:spPr>
-          <a:xfrm>
-            <a:off x="914400" y="1600200"/>
-            <a:ext cx="6583680" cy="4114800"/>
-          </a:xfrm>
-          <a:prstGeom prst="rect">
-            <a:avLst/>
-          </a:prstGeom>
-          <a:noFill/>
-          <a:ln/>
-        </p:spPr>
-        <p:txBody>
-          <a:bodyPr wrap="square" lIns="508" tIns="508" rIns="508" bIns="508" rtlCol="0" anchor="t">
-            <a:normAutofit/>
-          </a:bodyPr>
-          <a:lstStyle/>
-          <a:p>
-            <a:pPr marL="0" indent="0">
-              <a:buNone/>
-            </a:pPr>
-            <a:r>
-              <a:rPr lang="en-US" sz="2000" b="1" dirty="0">
-                <a:solidFill>
-                  <a:srgbClr val="2F80A6"/>
-                </a:solidFill>
-                <a:latin typeface="Aptos" pitchFamily="34" charset="0"/>
-                <a:ea typeface="Aptos" pitchFamily="34" charset="-122"/>
-                <a:cs typeface="Aptos" pitchFamily="34" charset="-120"/>
-              </a:rPr>
-              <a:t>• </a:t>
-            </a:r>
-            <a:r>
-              <a:rPr lang="en-US" sz="2000" b="1" dirty="0">
-                <a:solidFill>
-                  <a:srgbClr val="1E293B"/>
-                </a:solidFill>
-                <a:latin typeface="Aptos" pitchFamily="34" charset="0"/>
-                <a:ea typeface="Aptos" pitchFamily="34" charset="-122"/>
-                <a:cs typeface="Aptos" pitchFamily="34" charset="-120"/>
-              </a:rPr>
-              <a:t>Downsampling</a:t>
-            </a:r>
-            <a:r>
-              <a:rPr lang="en-US" sz="2000" dirty="0">
-                <a:solidFill>
-                  <a:srgbClr val="1E293B"/>
-                </a:solidFill>
-                <a:latin typeface="Aptos" pitchFamily="34" charset="0"/>
-                <a:ea typeface="Aptos" pitchFamily="34" charset="-122"/>
-                <a:cs typeface="Aptos" pitchFamily="34" charset="-120"/>
-              </a:rPr>
-              <a:t> changes the sample rate and stretches spectral copies.
-</a:t>
-            </a:r>
-            <a:r>
-              <a:rPr lang="en-US" sz="2000" b="1" dirty="0">
-                <a:solidFill>
-                  <a:srgbClr val="2F80A6"/>
-                </a:solidFill>
-                <a:latin typeface="Aptos" pitchFamily="34" charset="0"/>
-                <a:ea typeface="Aptos" pitchFamily="34" charset="-122"/>
-                <a:cs typeface="Aptos" pitchFamily="34" charset="-120"/>
-              </a:rPr>
-              <a:t>• </a:t>
-            </a:r>
-            <a:r>
-              <a:rPr lang="en-US" sz="2000" b="1" dirty="0">
-                <a:solidFill>
-                  <a:srgbClr val="1E293B"/>
-                </a:solidFill>
-                <a:latin typeface="Aptos" pitchFamily="34" charset="0"/>
-                <a:ea typeface="Aptos" pitchFamily="34" charset="-122"/>
-                <a:cs typeface="Aptos" pitchFamily="34" charset="-120"/>
-              </a:rPr>
-              <a:t>Aliasing</a:t>
-            </a:r>
-            <a:r>
-              <a:rPr lang="en-US" sz="2000" dirty="0">
-                <a:solidFill>
-                  <a:srgbClr val="1E293B"/>
-                </a:solidFill>
-                <a:latin typeface="Aptos" pitchFamily="34" charset="0"/>
-                <a:ea typeface="Aptos" pitchFamily="34" charset="-122"/>
-                <a:cs typeface="Aptos" pitchFamily="34" charset="-120"/>
-              </a:rPr>
-              <a:t> occurs when those copies overlap.
-</a:t>
-            </a:r>
-            <a:r>
-              <a:rPr lang="en-US" sz="2000" b="1" dirty="0">
-                <a:solidFill>
-                  <a:srgbClr val="2F80A6"/>
-                </a:solidFill>
-                <a:latin typeface="Aptos" pitchFamily="34" charset="0"/>
-                <a:ea typeface="Aptos" pitchFamily="34" charset="-122"/>
-                <a:cs typeface="Aptos" pitchFamily="34" charset="-120"/>
-              </a:rPr>
-              <a:t>• </a:t>
-            </a:r>
-            <a:r>
-              <a:rPr lang="en-US" sz="2000" b="1" dirty="0">
-                <a:solidFill>
-                  <a:srgbClr val="1E293B"/>
-                </a:solidFill>
-                <a:latin typeface="Aptos" pitchFamily="34" charset="0"/>
-                <a:ea typeface="Aptos" pitchFamily="34" charset="-122"/>
-                <a:cs typeface="Aptos" pitchFamily="34" charset="-120"/>
-              </a:rPr>
-              <a:t>Decimation</a:t>
-            </a:r>
-            <a:r>
-              <a:rPr lang="en-US" sz="2000" dirty="0">
-                <a:solidFill>
-                  <a:srgbClr val="1E293B"/>
-                </a:solidFill>
-                <a:latin typeface="Aptos" pitchFamily="34" charset="0"/>
-                <a:ea typeface="Aptos" pitchFamily="34" charset="-122"/>
-                <a:cs typeface="Aptos" pitchFamily="34" charset="-120"/>
-              </a:rPr>
-              <a:t> is anti-alias lowpass filtering followed by ↓M.
-</a:t>
-            </a:r>
-            <a:r>
-              <a:rPr lang="en-US" sz="2000" b="1" dirty="0">
-                <a:solidFill>
-                  <a:srgbClr val="2F80A6"/>
-                </a:solidFill>
-                <a:latin typeface="Aptos" pitchFamily="34" charset="0"/>
-                <a:ea typeface="Aptos" pitchFamily="34" charset="-122"/>
-                <a:cs typeface="Aptos" pitchFamily="34" charset="-120"/>
-              </a:rPr>
-              <a:t>• </a:t>
-            </a:r>
-            <a:r>
-              <a:rPr lang="en-US" sz="2000" b="1" dirty="0">
-                <a:solidFill>
-                  <a:srgbClr val="1E293B"/>
-                </a:solidFill>
-                <a:latin typeface="Aptos" pitchFamily="34" charset="0"/>
-                <a:ea typeface="Aptos" pitchFamily="34" charset="-122"/>
-                <a:cs typeface="Aptos" pitchFamily="34" charset="-120"/>
-              </a:rPr>
-              <a:t>Strided CNN layers</a:t>
-            </a:r>
-            <a:r>
-              <a:rPr lang="en-US" sz="2000" dirty="0">
-                <a:solidFill>
-                  <a:srgbClr val="1E293B"/>
-                </a:solidFill>
-                <a:latin typeface="Aptos" pitchFamily="34" charset="0"/>
-                <a:ea typeface="Aptos" pitchFamily="34" charset="-122"/>
-                <a:cs typeface="Aptos" pitchFamily="34" charset="-120"/>
-              </a:rPr>
-              <a:t> are learned-filter + downsample systems.
-</a:t>
-            </a:r>
-            <a:r>
-              <a:rPr lang="en-US" sz="2000" b="1" dirty="0">
-                <a:solidFill>
-                  <a:srgbClr val="2F80A6"/>
-                </a:solidFill>
-                <a:latin typeface="Aptos" pitchFamily="34" charset="0"/>
-                <a:ea typeface="Aptos" pitchFamily="34" charset="-122"/>
-                <a:cs typeface="Aptos" pitchFamily="34" charset="-120"/>
-              </a:rPr>
-              <a:t>• </a:t>
-            </a:r>
-            <a:r>
-              <a:rPr lang="en-US" sz="2000" b="1" dirty="0">
-                <a:solidFill>
-                  <a:srgbClr val="1E293B"/>
-                </a:solidFill>
-                <a:latin typeface="Aptos" pitchFamily="34" charset="0"/>
-                <a:ea typeface="Aptos" pitchFamily="34" charset="-122"/>
-                <a:cs typeface="Aptos" pitchFamily="34" charset="-120"/>
-              </a:rPr>
-              <a:t>Anti-aliased CNNs</a:t>
-            </a:r>
-            <a:r>
-              <a:rPr lang="en-US" sz="2000" dirty="0">
-                <a:solidFill>
-                  <a:srgbClr val="1E293B"/>
-                </a:solidFill>
-                <a:latin typeface="Aptos" pitchFamily="34" charset="0"/>
-                <a:ea typeface="Aptos" pitchFamily="34" charset="-122"/>
-                <a:cs typeface="Aptos" pitchFamily="34" charset="-120"/>
-              </a:rPr>
-              <a:t> reintroduce an explicit lowpass step before subsampling.</a:t>
-            </a:r>
-            <a:endParaRPr lang="en-US" sz="2000" dirty="0"/>
-          </a:p>
-        </p:txBody>
-      </p:sp>
-      <p:sp>
-        <p:nvSpPr>
-          <p:cNvPr id="5" name="Shape 3"/>
-          <p:cNvSpPr/>
-          <p:nvPr/>
-        </p:nvSpPr>
-        <p:spPr>
-          <a:xfrm>
-            <a:off x="8001000" y="2103120"/>
-            <a:ext cx="3383280" cy="1874520"/>
-          </a:xfrm>
-          <a:prstGeom prst="roundRect">
-            <a:avLst>
-              <a:gd name="adj" fmla="val 2927"/>
-            </a:avLst>
-          </a:prstGeom>
-          <a:solidFill>
-            <a:srgbClr val="FFF8EC"/>
-          </a:solidFill>
-          <a:ln w="12700">
-            <a:solidFill>
-              <a:srgbClr val="C9D6E2"/>
-            </a:solidFill>
-            <a:prstDash val="solid"/>
-          </a:ln>
-          <a:effectLst>
-            <a:outerShdw blurRad="16510" dist="8890" dir="2700000" algn="bl" rotWithShape="0">
-              <a:srgbClr val="000000">
-                <a:alpha val="12000"/>
-              </a:srgbClr>
-            </a:outerShdw>
-          </a:effectLst>
-        </p:spPr>
-        <p:txBody>
-          <a:bodyPr/>
-          <a:lstStyle/>
-          <a:p>
-            <a:endParaRPr lang="en-US"/>
-          </a:p>
-        </p:txBody>
-      </p:sp>
-      <p:sp>
-        <p:nvSpPr>
-          <p:cNvPr id="6" name="Text 4"/>
-          <p:cNvSpPr/>
-          <p:nvPr/>
-        </p:nvSpPr>
-        <p:spPr>
-          <a:xfrm>
-            <a:off x="8165592" y="2231136"/>
-            <a:ext cx="3054096" cy="256032"/>
-          </a:xfrm>
-          <a:prstGeom prst="rect">
-            <a:avLst/>
-          </a:prstGeom>
-          <a:noFill/>
-          <a:ln/>
-        </p:spPr>
-        <p:txBody>
-          <a:bodyPr wrap="square" lIns="0" tIns="0" rIns="0" bIns="0" rtlCol="0" anchor="ctr"/>
-          <a:lstStyle/>
-          <a:p>
-            <a:pPr marL="0" indent="0">
-              <a:buNone/>
-            </a:pPr>
-            <a:r>
-              <a:rPr lang="en-US" sz="1200" b="1" dirty="0">
-                <a:solidFill>
-                  <a:srgbClr val="16324F"/>
-                </a:solidFill>
-                <a:latin typeface="Aptos" pitchFamily="34" charset="0"/>
-                <a:ea typeface="Aptos" pitchFamily="34" charset="-122"/>
-                <a:cs typeface="Aptos" pitchFamily="34" charset="-120"/>
-              </a:rPr>
-              <a:t>Exit question</a:t>
-            </a:r>
-            <a:endParaRPr lang="en-US" sz="1200" dirty="0"/>
-          </a:p>
-        </p:txBody>
-      </p:sp>
-      <p:sp>
-        <p:nvSpPr>
-          <p:cNvPr id="7" name="Text 5"/>
-          <p:cNvSpPr/>
-          <p:nvPr/>
-        </p:nvSpPr>
-        <p:spPr>
-          <a:xfrm>
-            <a:off x="8165592" y="2542032"/>
-            <a:ext cx="3054096" cy="1325880"/>
-          </a:xfrm>
-          <a:prstGeom prst="rect">
-            <a:avLst/>
-          </a:prstGeom>
-          <a:noFill/>
-          <a:ln/>
-        </p:spPr>
-        <p:txBody>
-          <a:bodyPr wrap="square" lIns="0" tIns="0" rIns="0" bIns="0" rtlCol="0" anchor="ctr">
-            <a:normAutofit/>
-          </a:bodyPr>
-          <a:lstStyle/>
-          <a:p>
-            <a:pPr marL="0" indent="0">
-              <a:buNone/>
-            </a:pPr>
-            <a:r>
-              <a:rPr lang="en-US" sz="1350" dirty="0">
-                <a:solidFill>
-                  <a:srgbClr val="1E293B"/>
-                </a:solidFill>
-                <a:latin typeface="Aptos" pitchFamily="34" charset="0"/>
-                <a:ea typeface="Aptos" pitchFamily="34" charset="-122"/>
-                <a:cs typeface="Aptos" pitchFamily="34" charset="-120"/>
-              </a:rPr>
-              <a:t>In one sentence: why can a perfectly reasonable learned convolution still be a poor anti-aliasing filter?</a:t>
-            </a:r>
-            <a:endParaRPr lang="en-US" sz="1350" dirty="0"/>
-          </a:p>
-        </p:txBody>
-      </p:sp>
-      <p:sp>
-        <p:nvSpPr>
-          <p:cNvPr id="8" name="Shape 6"/>
-          <p:cNvSpPr/>
-          <p:nvPr/>
-        </p:nvSpPr>
-        <p:spPr>
-          <a:xfrm>
-            <a:off x="8001000" y="4343400"/>
-            <a:ext cx="3383280" cy="1188720"/>
-          </a:xfrm>
-          <a:prstGeom prst="roundRect">
-            <a:avLst>
-              <a:gd name="adj" fmla="val 4615"/>
-            </a:avLst>
-          </a:prstGeom>
-          <a:solidFill>
-            <a:srgbClr val="EEF7F1"/>
-          </a:solidFill>
-          <a:ln w="12700">
-            <a:solidFill>
-              <a:srgbClr val="C9D6E2"/>
-            </a:solidFill>
-            <a:prstDash val="solid"/>
-          </a:ln>
-          <a:effectLst>
-            <a:outerShdw blurRad="16510" dist="8890" dir="2700000" algn="bl" rotWithShape="0">
-              <a:srgbClr val="000000">
-                <a:alpha val="12000"/>
-              </a:srgbClr>
-            </a:outerShdw>
-          </a:effectLst>
-        </p:spPr>
-        <p:txBody>
-          <a:bodyPr/>
-          <a:lstStyle/>
-          <a:p>
-            <a:endParaRPr lang="en-US"/>
-          </a:p>
-        </p:txBody>
-      </p:sp>
-      <p:sp>
-        <p:nvSpPr>
-          <p:cNvPr id="9" name="Text 7"/>
-          <p:cNvSpPr/>
-          <p:nvPr/>
-        </p:nvSpPr>
-        <p:spPr>
-          <a:xfrm>
-            <a:off x="8165592" y="4471416"/>
-            <a:ext cx="3054096" cy="256032"/>
-          </a:xfrm>
-          <a:prstGeom prst="rect">
-            <a:avLst/>
-          </a:prstGeom>
-          <a:noFill/>
-          <a:ln/>
-        </p:spPr>
-        <p:txBody>
-          <a:bodyPr wrap="square" lIns="0" tIns="0" rIns="0" bIns="0" rtlCol="0" anchor="ctr"/>
-          <a:lstStyle/>
-          <a:p>
-            <a:pPr marL="0" indent="0">
-              <a:buNone/>
-            </a:pPr>
-            <a:r>
-              <a:rPr lang="en-US" sz="1200" b="1" dirty="0">
-                <a:solidFill>
-                  <a:srgbClr val="16324F"/>
-                </a:solidFill>
-                <a:latin typeface="Aptos" pitchFamily="34" charset="0"/>
-                <a:ea typeface="Aptos" pitchFamily="34" charset="-122"/>
-                <a:cs typeface="Aptos" pitchFamily="34" charset="-120"/>
-              </a:rPr>
-              <a:t>Next lecture</a:t>
-            </a:r>
-            <a:endParaRPr lang="en-US" sz="1200" dirty="0"/>
-          </a:p>
-        </p:txBody>
-      </p:sp>
-      <p:sp>
-        <p:nvSpPr>
-          <p:cNvPr id="10" name="Text 8"/>
-          <p:cNvSpPr/>
-          <p:nvPr/>
-        </p:nvSpPr>
-        <p:spPr>
-          <a:xfrm>
-            <a:off x="8165592" y="4782312"/>
-            <a:ext cx="3054096" cy="640080"/>
-          </a:xfrm>
-          <a:prstGeom prst="rect">
-            <a:avLst/>
-          </a:prstGeom>
-          <a:noFill/>
-          <a:ln/>
-        </p:spPr>
-        <p:txBody>
-          <a:bodyPr wrap="square" lIns="0" tIns="0" rIns="0" bIns="0" rtlCol="0" anchor="ctr">
-            <a:normAutofit/>
-          </a:bodyPr>
-          <a:lstStyle/>
-          <a:p>
-            <a:pPr marL="0" indent="0">
-              <a:buNone/>
-            </a:pPr>
-            <a:r>
-              <a:rPr lang="en-US" sz="1350" dirty="0">
-                <a:solidFill>
-                  <a:srgbClr val="1E293B"/>
-                </a:solidFill>
-                <a:latin typeface="Aptos" pitchFamily="34" charset="0"/>
-                <a:ea typeface="Aptos" pitchFamily="34" charset="-122"/>
-                <a:cs typeface="Aptos" pitchFamily="34" charset="-120"/>
-              </a:rPr>
-              <a:t>Zero insertion creates images; interpolation removes them.</a:t>
-            </a:r>
-            <a:endParaRPr lang="en-US" sz="1350" dirty="0"/>
-          </a:p>
-        </p:txBody>
-      </p:sp>
-      <p:sp>
-        <p:nvSpPr>
-          <p:cNvPr id="25" name="Slide Number Placeholder 0"/>
-          <p:cNvSpPr>
-            <a:spLocks noGrp="1"/>
-          </p:cNvSpPr>
-          <p:nvPr>
-            <p:ph type="sldNum" sz="quarter" idx="4294967295"/>
-          </p:nvPr>
-        </p:nvSpPr>
-        <p:spPr>
-          <a:xfrm>
-            <a:off x="11722608" y="6492240"/>
-            <a:ext cx="228600" cy="182880"/>
-          </a:xfrm>
-          <a:prstGeom prst="rect">
-            <a:avLst/>
-          </a:prstGeom>
-          <a:extLst>
-            <a:ext uri="{C572A759-6A51-4108-AA02-DFA0A04FC94B}">
-              <ma14:wrappingTextBoxFlag xmlns:ma14="http://schemas.microsoft.com/office/mac/drawingml/2011/main" xmlns="" val="0"/>
+              <ma14:wrappingTextBoxFlag xmlns="" xmlns:ma14="http://schemas.microsoft.com/office/mac/drawingml/2011/main" val="0"/>
             </a:ext>
           </a:extLst>
         </p:spPr>
@@ -8809,6 +8322,600 @@
 
 <file path=ppt/slides/slide20.xml><?xml version="1.0" encoding="utf-8"?>
 <p:sld xmlns:a="http://schemas.openxmlformats.org/drawingml/2006/main" xmlns:r="http://schemas.openxmlformats.org/officeDocument/2006/relationships" xmlns:p="http://schemas.openxmlformats.org/presentationml/2006/main">
+  <p:cSld name="Slide 18">
+    <p:spTree>
+      <p:nvGrpSpPr>
+        <p:cNvPr id="1" name=""/>
+        <p:cNvGrpSpPr/>
+        <p:nvPr/>
+      </p:nvGrpSpPr>
+      <p:grpSpPr>
+        <a:xfrm>
+          <a:off x="0" y="0"/>
+          <a:ext cx="0" cy="0"/>
+          <a:chOff x="0" y="0"/>
+          <a:chExt cx="0" cy="0"/>
+        </a:xfrm>
+      </p:grpSpPr>
+      <p:sp>
+        <p:nvSpPr>
+          <p:cNvPr id="2" name="Text 0"/>
+          <p:cNvSpPr/>
+          <p:nvPr/>
+        </p:nvSpPr>
+        <p:spPr>
+          <a:xfrm>
+            <a:off x="530352" y="347472"/>
+            <a:ext cx="2743200" cy="228600"/>
+          </a:xfrm>
+          <a:prstGeom prst="rect">
+            <a:avLst/>
+          </a:prstGeom>
+          <a:noFill/>
+          <a:ln/>
+        </p:spPr>
+        <p:txBody>
+          <a:bodyPr wrap="square" lIns="0" tIns="0" rIns="0" bIns="0" rtlCol="0" anchor="ctr"/>
+          <a:lstStyle/>
+          <a:p>
+            <a:pPr marL="0" indent="0">
+              <a:buNone/>
+            </a:pPr>
+            <a:r>
+              <a:rPr lang="en-US" sz="1000" b="1" dirty="0">
+                <a:solidFill>
+                  <a:srgbClr val="2F80A6"/>
+                </a:solidFill>
+                <a:latin typeface="Aptos" pitchFamily="34" charset="0"/>
+                <a:ea typeface="Aptos" pitchFamily="34" charset="-122"/>
+                <a:cs typeface="Aptos" pitchFamily="34" charset="-120"/>
+              </a:rPr>
+              <a:t>1:14–1:15</a:t>
+            </a:r>
+            <a:endParaRPr lang="en-US" sz="1000" dirty="0"/>
+          </a:p>
+        </p:txBody>
+      </p:sp>
+      <p:sp>
+        <p:nvSpPr>
+          <p:cNvPr id="3" name="Text 1"/>
+          <p:cNvSpPr/>
+          <p:nvPr/>
+        </p:nvSpPr>
+        <p:spPr>
+          <a:xfrm>
+            <a:off x="530352" y="621792"/>
+            <a:ext cx="11018520" cy="566928"/>
+          </a:xfrm>
+          <a:prstGeom prst="rect">
+            <a:avLst/>
+          </a:prstGeom>
+          <a:noFill/>
+          <a:ln/>
+        </p:spPr>
+        <p:txBody>
+          <a:bodyPr wrap="square" lIns="0" tIns="0" rIns="0" bIns="0" rtlCol="0" anchor="ctr">
+            <a:normAutofit/>
+          </a:bodyPr>
+          <a:lstStyle/>
+          <a:p>
+            <a:pPr marL="0" indent="0">
+              <a:buNone/>
+            </a:pPr>
+            <a:r>
+              <a:rPr lang="en-US" sz="2550" b="1" dirty="0">
+                <a:solidFill>
+                  <a:srgbClr val="16324F"/>
+                </a:solidFill>
+                <a:latin typeface="Aptos" pitchFamily="34" charset="0"/>
+                <a:ea typeface="Aptos" pitchFamily="34" charset="-122"/>
+                <a:cs typeface="Aptos" pitchFamily="34" charset="-120"/>
+              </a:rPr>
+              <a:t>Lecture 13 wrap-up</a:t>
+            </a:r>
+            <a:endParaRPr lang="en-US" sz="2550" dirty="0"/>
+          </a:p>
+        </p:txBody>
+      </p:sp>
+      <p:sp>
+        <p:nvSpPr>
+          <p:cNvPr id="4" name="Text 2"/>
+          <p:cNvSpPr/>
+          <p:nvPr/>
+        </p:nvSpPr>
+        <p:spPr>
+          <a:xfrm>
+            <a:off x="914400" y="1600200"/>
+            <a:ext cx="6583680" cy="4114800"/>
+          </a:xfrm>
+          <a:prstGeom prst="rect">
+            <a:avLst/>
+          </a:prstGeom>
+          <a:noFill/>
+          <a:ln/>
+        </p:spPr>
+        <p:txBody>
+          <a:bodyPr wrap="square" lIns="508" tIns="508" rIns="508" bIns="508" rtlCol="0" anchor="t">
+            <a:normAutofit/>
+          </a:bodyPr>
+          <a:lstStyle/>
+          <a:p>
+            <a:pPr marL="0" indent="0">
+              <a:buNone/>
+            </a:pPr>
+            <a:r>
+              <a:rPr lang="en-US" sz="2000" b="1" dirty="0">
+                <a:solidFill>
+                  <a:srgbClr val="2F80A6"/>
+                </a:solidFill>
+                <a:latin typeface="Aptos" pitchFamily="34" charset="0"/>
+                <a:ea typeface="Aptos" pitchFamily="34" charset="-122"/>
+                <a:cs typeface="Aptos" pitchFamily="34" charset="-120"/>
+              </a:rPr>
+              <a:t>• </a:t>
+            </a:r>
+            <a:r>
+              <a:rPr lang="en-US" sz="2000" b="1" dirty="0">
+                <a:solidFill>
+                  <a:srgbClr val="1E293B"/>
+                </a:solidFill>
+                <a:latin typeface="Aptos" pitchFamily="34" charset="0"/>
+                <a:ea typeface="Aptos" pitchFamily="34" charset="-122"/>
+                <a:cs typeface="Aptos" pitchFamily="34" charset="-120"/>
+              </a:rPr>
+              <a:t>Downsampling</a:t>
+            </a:r>
+            <a:r>
+              <a:rPr lang="en-US" sz="2000" dirty="0">
+                <a:solidFill>
+                  <a:srgbClr val="1E293B"/>
+                </a:solidFill>
+                <a:latin typeface="Aptos" pitchFamily="34" charset="0"/>
+                <a:ea typeface="Aptos" pitchFamily="34" charset="-122"/>
+                <a:cs typeface="Aptos" pitchFamily="34" charset="-120"/>
+              </a:rPr>
+              <a:t> changes the sample rate and stretches spectral copies.
+</a:t>
+            </a:r>
+            <a:r>
+              <a:rPr lang="en-US" sz="2000" b="1" dirty="0">
+                <a:solidFill>
+                  <a:srgbClr val="2F80A6"/>
+                </a:solidFill>
+                <a:latin typeface="Aptos" pitchFamily="34" charset="0"/>
+                <a:ea typeface="Aptos" pitchFamily="34" charset="-122"/>
+                <a:cs typeface="Aptos" pitchFamily="34" charset="-120"/>
+              </a:rPr>
+              <a:t>• </a:t>
+            </a:r>
+            <a:r>
+              <a:rPr lang="en-US" sz="2000" b="1" dirty="0">
+                <a:solidFill>
+                  <a:srgbClr val="1E293B"/>
+                </a:solidFill>
+                <a:latin typeface="Aptos" pitchFamily="34" charset="0"/>
+                <a:ea typeface="Aptos" pitchFamily="34" charset="-122"/>
+                <a:cs typeface="Aptos" pitchFamily="34" charset="-120"/>
+              </a:rPr>
+              <a:t>Aliasing</a:t>
+            </a:r>
+            <a:r>
+              <a:rPr lang="en-US" sz="2000" dirty="0">
+                <a:solidFill>
+                  <a:srgbClr val="1E293B"/>
+                </a:solidFill>
+                <a:latin typeface="Aptos" pitchFamily="34" charset="0"/>
+                <a:ea typeface="Aptos" pitchFamily="34" charset="-122"/>
+                <a:cs typeface="Aptos" pitchFamily="34" charset="-120"/>
+              </a:rPr>
+              <a:t> occurs when those copies overlap.
+</a:t>
+            </a:r>
+            <a:r>
+              <a:rPr lang="en-US" sz="2000" b="1" dirty="0">
+                <a:solidFill>
+                  <a:srgbClr val="2F80A6"/>
+                </a:solidFill>
+                <a:latin typeface="Aptos" pitchFamily="34" charset="0"/>
+                <a:ea typeface="Aptos" pitchFamily="34" charset="-122"/>
+                <a:cs typeface="Aptos" pitchFamily="34" charset="-120"/>
+              </a:rPr>
+              <a:t>• </a:t>
+            </a:r>
+            <a:r>
+              <a:rPr lang="en-US" sz="2000" b="1" dirty="0">
+                <a:solidFill>
+                  <a:srgbClr val="1E293B"/>
+                </a:solidFill>
+                <a:latin typeface="Aptos" pitchFamily="34" charset="0"/>
+                <a:ea typeface="Aptos" pitchFamily="34" charset="-122"/>
+                <a:cs typeface="Aptos" pitchFamily="34" charset="-120"/>
+              </a:rPr>
+              <a:t>Decimation</a:t>
+            </a:r>
+            <a:r>
+              <a:rPr lang="en-US" sz="2000" dirty="0">
+                <a:solidFill>
+                  <a:srgbClr val="1E293B"/>
+                </a:solidFill>
+                <a:latin typeface="Aptos" pitchFamily="34" charset="0"/>
+                <a:ea typeface="Aptos" pitchFamily="34" charset="-122"/>
+                <a:cs typeface="Aptos" pitchFamily="34" charset="-120"/>
+              </a:rPr>
+              <a:t> is anti-alias lowpass filtering followed by ↓M.
+</a:t>
+            </a:r>
+            <a:r>
+              <a:rPr lang="en-US" sz="2000" b="1" dirty="0">
+                <a:solidFill>
+                  <a:srgbClr val="2F80A6"/>
+                </a:solidFill>
+                <a:latin typeface="Aptos" pitchFamily="34" charset="0"/>
+                <a:ea typeface="Aptos" pitchFamily="34" charset="-122"/>
+                <a:cs typeface="Aptos" pitchFamily="34" charset="-120"/>
+              </a:rPr>
+              <a:t>• </a:t>
+            </a:r>
+            <a:r>
+              <a:rPr lang="en-US" sz="2000" b="1" dirty="0">
+                <a:solidFill>
+                  <a:srgbClr val="1E293B"/>
+                </a:solidFill>
+                <a:latin typeface="Aptos" pitchFamily="34" charset="0"/>
+                <a:ea typeface="Aptos" pitchFamily="34" charset="-122"/>
+                <a:cs typeface="Aptos" pitchFamily="34" charset="-120"/>
+              </a:rPr>
+              <a:t>Strided CNN layers</a:t>
+            </a:r>
+            <a:r>
+              <a:rPr lang="en-US" sz="2000" dirty="0">
+                <a:solidFill>
+                  <a:srgbClr val="1E293B"/>
+                </a:solidFill>
+                <a:latin typeface="Aptos" pitchFamily="34" charset="0"/>
+                <a:ea typeface="Aptos" pitchFamily="34" charset="-122"/>
+                <a:cs typeface="Aptos" pitchFamily="34" charset="-120"/>
+              </a:rPr>
+              <a:t> are learned-filter + downsample systems.
+</a:t>
+            </a:r>
+            <a:r>
+              <a:rPr lang="en-US" sz="2000" b="1" dirty="0">
+                <a:solidFill>
+                  <a:srgbClr val="2F80A6"/>
+                </a:solidFill>
+                <a:latin typeface="Aptos" pitchFamily="34" charset="0"/>
+                <a:ea typeface="Aptos" pitchFamily="34" charset="-122"/>
+                <a:cs typeface="Aptos" pitchFamily="34" charset="-120"/>
+              </a:rPr>
+              <a:t>• </a:t>
+            </a:r>
+            <a:r>
+              <a:rPr lang="en-US" sz="2000" b="1" dirty="0">
+                <a:solidFill>
+                  <a:srgbClr val="1E293B"/>
+                </a:solidFill>
+                <a:latin typeface="Aptos" pitchFamily="34" charset="0"/>
+                <a:ea typeface="Aptos" pitchFamily="34" charset="-122"/>
+                <a:cs typeface="Aptos" pitchFamily="34" charset="-120"/>
+              </a:rPr>
+              <a:t>Anti-aliased CNNs</a:t>
+            </a:r>
+            <a:r>
+              <a:rPr lang="en-US" sz="2000" dirty="0">
+                <a:solidFill>
+                  <a:srgbClr val="1E293B"/>
+                </a:solidFill>
+                <a:latin typeface="Aptos" pitchFamily="34" charset="0"/>
+                <a:ea typeface="Aptos" pitchFamily="34" charset="-122"/>
+                <a:cs typeface="Aptos" pitchFamily="34" charset="-120"/>
+              </a:rPr>
+              <a:t> reintroduce an explicit lowpass step before subsampling.</a:t>
+            </a:r>
+            <a:endParaRPr lang="en-US" sz="2000" dirty="0"/>
+          </a:p>
+        </p:txBody>
+      </p:sp>
+      <p:sp>
+        <p:nvSpPr>
+          <p:cNvPr id="5" name="Shape 3"/>
+          <p:cNvSpPr/>
+          <p:nvPr/>
+        </p:nvSpPr>
+        <p:spPr>
+          <a:xfrm>
+            <a:off x="8001000" y="2103120"/>
+            <a:ext cx="3383280" cy="1874520"/>
+          </a:xfrm>
+          <a:prstGeom prst="roundRect">
+            <a:avLst>
+              <a:gd name="adj" fmla="val 2927"/>
+            </a:avLst>
+          </a:prstGeom>
+          <a:solidFill>
+            <a:srgbClr val="FFF8EC"/>
+          </a:solidFill>
+          <a:ln w="12700">
+            <a:solidFill>
+              <a:srgbClr val="C9D6E2"/>
+            </a:solidFill>
+            <a:prstDash val="solid"/>
+          </a:ln>
+          <a:effectLst>
+            <a:outerShdw blurRad="16510" dist="8890" dir="2700000" algn="bl" rotWithShape="0">
+              <a:srgbClr val="000000">
+                <a:alpha val="12000"/>
+              </a:srgbClr>
+            </a:outerShdw>
+          </a:effectLst>
+        </p:spPr>
+        <p:txBody>
+          <a:bodyPr/>
+          <a:lstStyle/>
+          <a:p>
+            <a:endParaRPr lang="en-US"/>
+          </a:p>
+        </p:txBody>
+      </p:sp>
+      <p:sp>
+        <p:nvSpPr>
+          <p:cNvPr id="6" name="Text 4"/>
+          <p:cNvSpPr/>
+          <p:nvPr/>
+        </p:nvSpPr>
+        <p:spPr>
+          <a:xfrm>
+            <a:off x="8165592" y="2231136"/>
+            <a:ext cx="3054096" cy="256032"/>
+          </a:xfrm>
+          <a:prstGeom prst="rect">
+            <a:avLst/>
+          </a:prstGeom>
+          <a:noFill/>
+          <a:ln/>
+        </p:spPr>
+        <p:txBody>
+          <a:bodyPr wrap="square" lIns="0" tIns="0" rIns="0" bIns="0" rtlCol="0" anchor="ctr"/>
+          <a:lstStyle/>
+          <a:p>
+            <a:pPr marL="0" indent="0">
+              <a:buNone/>
+            </a:pPr>
+            <a:r>
+              <a:rPr lang="en-US" sz="1200" b="1" dirty="0">
+                <a:solidFill>
+                  <a:srgbClr val="16324F"/>
+                </a:solidFill>
+                <a:latin typeface="Aptos" pitchFamily="34" charset="0"/>
+                <a:ea typeface="Aptos" pitchFamily="34" charset="-122"/>
+                <a:cs typeface="Aptos" pitchFamily="34" charset="-120"/>
+              </a:rPr>
+              <a:t>Exit question</a:t>
+            </a:r>
+            <a:endParaRPr lang="en-US" sz="1200" dirty="0"/>
+          </a:p>
+        </p:txBody>
+      </p:sp>
+      <p:sp>
+        <p:nvSpPr>
+          <p:cNvPr id="7" name="Text 5"/>
+          <p:cNvSpPr/>
+          <p:nvPr/>
+        </p:nvSpPr>
+        <p:spPr>
+          <a:xfrm>
+            <a:off x="8165592" y="2542032"/>
+            <a:ext cx="3054096" cy="1325880"/>
+          </a:xfrm>
+          <a:prstGeom prst="rect">
+            <a:avLst/>
+          </a:prstGeom>
+          <a:noFill/>
+          <a:ln/>
+        </p:spPr>
+        <p:txBody>
+          <a:bodyPr wrap="square" lIns="0" tIns="0" rIns="0" bIns="0" rtlCol="0" anchor="ctr">
+            <a:normAutofit/>
+          </a:bodyPr>
+          <a:lstStyle/>
+          <a:p>
+            <a:pPr marL="0" indent="0">
+              <a:buNone/>
+            </a:pPr>
+            <a:r>
+              <a:rPr lang="en-US" sz="1350" dirty="0">
+                <a:solidFill>
+                  <a:srgbClr val="1E293B"/>
+                </a:solidFill>
+                <a:latin typeface="Aptos" pitchFamily="34" charset="0"/>
+                <a:ea typeface="Aptos" pitchFamily="34" charset="-122"/>
+                <a:cs typeface="Aptos" pitchFamily="34" charset="-120"/>
+              </a:rPr>
+              <a:t>In one sentence: why can a perfectly reasonable learned convolution still be a poor anti-aliasing filter?</a:t>
+            </a:r>
+            <a:endParaRPr lang="en-US" sz="1350" dirty="0"/>
+          </a:p>
+        </p:txBody>
+      </p:sp>
+      <p:sp>
+        <p:nvSpPr>
+          <p:cNvPr id="8" name="Shape 6"/>
+          <p:cNvSpPr/>
+          <p:nvPr/>
+        </p:nvSpPr>
+        <p:spPr>
+          <a:xfrm>
+            <a:off x="8001000" y="4343400"/>
+            <a:ext cx="3383280" cy="1188720"/>
+          </a:xfrm>
+          <a:prstGeom prst="roundRect">
+            <a:avLst>
+              <a:gd name="adj" fmla="val 4615"/>
+            </a:avLst>
+          </a:prstGeom>
+          <a:solidFill>
+            <a:srgbClr val="EEF7F1"/>
+          </a:solidFill>
+          <a:ln w="12700">
+            <a:solidFill>
+              <a:srgbClr val="C9D6E2"/>
+            </a:solidFill>
+            <a:prstDash val="solid"/>
+          </a:ln>
+          <a:effectLst>
+            <a:outerShdw blurRad="16510" dist="8890" dir="2700000" algn="bl" rotWithShape="0">
+              <a:srgbClr val="000000">
+                <a:alpha val="12000"/>
+              </a:srgbClr>
+            </a:outerShdw>
+          </a:effectLst>
+        </p:spPr>
+        <p:txBody>
+          <a:bodyPr/>
+          <a:lstStyle/>
+          <a:p>
+            <a:endParaRPr lang="en-US"/>
+          </a:p>
+        </p:txBody>
+      </p:sp>
+      <p:sp>
+        <p:nvSpPr>
+          <p:cNvPr id="9" name="Text 7"/>
+          <p:cNvSpPr/>
+          <p:nvPr/>
+        </p:nvSpPr>
+        <p:spPr>
+          <a:xfrm>
+            <a:off x="8165592" y="4471416"/>
+            <a:ext cx="3054096" cy="256032"/>
+          </a:xfrm>
+          <a:prstGeom prst="rect">
+            <a:avLst/>
+          </a:prstGeom>
+          <a:noFill/>
+          <a:ln/>
+        </p:spPr>
+        <p:txBody>
+          <a:bodyPr wrap="square" lIns="0" tIns="0" rIns="0" bIns="0" rtlCol="0" anchor="ctr"/>
+          <a:lstStyle/>
+          <a:p>
+            <a:pPr marL="0" indent="0">
+              <a:buNone/>
+            </a:pPr>
+            <a:r>
+              <a:rPr lang="en-US" sz="1200" b="1" dirty="0">
+                <a:solidFill>
+                  <a:srgbClr val="16324F"/>
+                </a:solidFill>
+                <a:latin typeface="Aptos" pitchFamily="34" charset="0"/>
+                <a:ea typeface="Aptos" pitchFamily="34" charset="-122"/>
+                <a:cs typeface="Aptos" pitchFamily="34" charset="-120"/>
+              </a:rPr>
+              <a:t>Next lecture</a:t>
+            </a:r>
+            <a:endParaRPr lang="en-US" sz="1200" dirty="0"/>
+          </a:p>
+        </p:txBody>
+      </p:sp>
+      <p:sp>
+        <p:nvSpPr>
+          <p:cNvPr id="10" name="Text 8"/>
+          <p:cNvSpPr/>
+          <p:nvPr/>
+        </p:nvSpPr>
+        <p:spPr>
+          <a:xfrm>
+            <a:off x="8165592" y="4782312"/>
+            <a:ext cx="3054096" cy="640080"/>
+          </a:xfrm>
+          <a:prstGeom prst="rect">
+            <a:avLst/>
+          </a:prstGeom>
+          <a:noFill/>
+          <a:ln/>
+        </p:spPr>
+        <p:txBody>
+          <a:bodyPr wrap="square" lIns="0" tIns="0" rIns="0" bIns="0" rtlCol="0" anchor="ctr">
+            <a:normAutofit/>
+          </a:bodyPr>
+          <a:lstStyle/>
+          <a:p>
+            <a:pPr marL="0" indent="0">
+              <a:buNone/>
+            </a:pPr>
+            <a:r>
+              <a:rPr lang="en-US" sz="1350" dirty="0">
+                <a:solidFill>
+                  <a:srgbClr val="1E293B"/>
+                </a:solidFill>
+                <a:latin typeface="Aptos" pitchFamily="34" charset="0"/>
+                <a:ea typeface="Aptos" pitchFamily="34" charset="-122"/>
+                <a:cs typeface="Aptos" pitchFamily="34" charset="-120"/>
+              </a:rPr>
+              <a:t>Zero insertion creates images; interpolation removes them.</a:t>
+            </a:r>
+            <a:endParaRPr lang="en-US" sz="1350" dirty="0"/>
+          </a:p>
+        </p:txBody>
+      </p:sp>
+      <p:sp>
+        <p:nvSpPr>
+          <p:cNvPr id="25" name="Slide Number Placeholder 0"/>
+          <p:cNvSpPr>
+            <a:spLocks noGrp="1"/>
+          </p:cNvSpPr>
+          <p:nvPr>
+            <p:ph type="sldNum" sz="quarter" idx="4294967295"/>
+          </p:nvPr>
+        </p:nvSpPr>
+        <p:spPr>
+          <a:xfrm>
+            <a:off x="11722608" y="6492240"/>
+            <a:ext cx="228600" cy="182880"/>
+          </a:xfrm>
+          <a:prstGeom prst="rect">
+            <a:avLst/>
+          </a:prstGeom>
+          <a:extLst>
+            <a:ext uri="{C572A759-6A51-4108-AA02-DFA0A04FC94B}">
+              <ma14:wrappingTextBoxFlag xmlns="" xmlns:ma14="http://schemas.microsoft.com/office/mac/drawingml/2011/main" val="0"/>
+            </a:ext>
+          </a:extLst>
+        </p:spPr>
+        <p:txBody>
+          <a:bodyPr/>
+          <a:lstStyle>
+            <a:lvl1pPr>
+              <a:defRPr sz="850">
+                <a:solidFill>
+                  <a:srgbClr val="5B677A"/>
+                </a:solidFill>
+                <a:latin typeface="Aptos"/>
+                <a:ea typeface="Aptos"/>
+                <a:cs typeface="Aptos"/>
+              </a:defRPr>
+            </a:lvl1pPr>
+          </a:lstStyle>
+          <a:p>
+            <a:pPr algn="r"/>
+            <a:fld id="{F7021451-1387-4CA6-816F-3879F97B5CBC}" type="slidenum">
+              <a:rPr lang="en-US" b="0"/>
+              <a:t>20</a:t>
+            </a:fld>
+            <a:endParaRPr lang="en-US"/>
+          </a:p>
+        </p:txBody>
+      </p:sp>
+    </p:spTree>
+  </p:cSld>
+  <p:clrMapOvr>
+    <a:masterClrMapping/>
+  </p:clrMapOvr>
+</p:sld>
+</file>
+
+<file path=ppt/slides/slide21.xml><?xml version="1.0" encoding="utf-8"?>
+<p:sld xmlns:a="http://schemas.openxmlformats.org/drawingml/2006/main" xmlns:r="http://schemas.openxmlformats.org/officeDocument/2006/relationships" xmlns:p="http://schemas.openxmlformats.org/presentationml/2006/main">
   <p:cSld name="Slide 19">
     <p:spTree>
       <p:nvGrpSpPr>
@@ -9045,7 +9152,7 @@
           </a:prstGeom>
           <a:extLst>
             <a:ext uri="{C572A759-6A51-4108-AA02-DFA0A04FC94B}">
-              <ma14:wrappingTextBoxFlag xmlns:ma14="http://schemas.microsoft.com/office/mac/drawingml/2011/main" xmlns="" val="0"/>
+              <ma14:wrappingTextBoxFlag xmlns="" xmlns:ma14="http://schemas.microsoft.com/office/mac/drawingml/2011/main" val="0"/>
             </a:ext>
           </a:extLst>
         </p:spPr>
@@ -9067,7 +9174,7 @@
             <a:pPr algn="r"/>
             <a:fld id="{F7021451-1387-4CA6-816F-3879F97B5CBC}" type="slidenum">
               <a:rPr lang="en-US" b="0"/>
-              <a:t>20</a:t>
+              <a:t>21</a:t>
             </a:fld>
             <a:endParaRPr lang="en-US"/>
           </a:p>
@@ -9769,7 +9876,7 @@
           </a:prstGeom>
           <a:extLst>
             <a:ext uri="{C572A759-6A51-4108-AA02-DFA0A04FC94B}">
-              <ma14:wrappingTextBoxFlag xmlns:ma14="http://schemas.microsoft.com/office/mac/drawingml/2011/main" xmlns="" val="0"/>
+              <ma14:wrappingTextBoxFlag xmlns="" xmlns:ma14="http://schemas.microsoft.com/office/mac/drawingml/2011/main" val="0"/>
             </a:ext>
           </a:extLst>
         </p:spPr>
@@ -10322,7 +10429,7 @@
           </a:prstGeom>
           <a:extLst>
             <a:ext uri="{C572A759-6A51-4108-AA02-DFA0A04FC94B}">
-              <ma14:wrappingTextBoxFlag xmlns:ma14="http://schemas.microsoft.com/office/mac/drawingml/2011/main" xmlns="" val="0"/>
+              <ma14:wrappingTextBoxFlag xmlns="" xmlns:ma14="http://schemas.microsoft.com/office/mac/drawingml/2011/main" val="0"/>
             </a:ext>
           </a:extLst>
         </p:spPr>
@@ -11815,7 +11922,7 @@
           </a:prstGeom>
           <a:extLst>
             <a:ext uri="{C572A759-6A51-4108-AA02-DFA0A04FC94B}">
-              <ma14:wrappingTextBoxFlag xmlns:ma14="http://schemas.microsoft.com/office/mac/drawingml/2011/main" xmlns="" val="0"/>
+              <ma14:wrappingTextBoxFlag xmlns="" xmlns:ma14="http://schemas.microsoft.com/office/mac/drawingml/2011/main" val="0"/>
             </a:ext>
           </a:extLst>
         </p:spPr>
@@ -12497,7 +12604,7 @@
           </a:prstGeom>
           <a:extLst>
             <a:ext uri="{C572A759-6A51-4108-AA02-DFA0A04FC94B}">
-              <ma14:wrappingTextBoxFlag xmlns:ma14="http://schemas.microsoft.com/office/mac/drawingml/2011/main" xmlns="" val="0"/>
+              <ma14:wrappingTextBoxFlag xmlns="" xmlns:ma14="http://schemas.microsoft.com/office/mac/drawingml/2011/main" val="0"/>
             </a:ext>
           </a:extLst>
         </p:spPr>
@@ -12819,7 +12926,7 @@
           </a:prstGeom>
           <a:extLst>
             <a:ext uri="{C572A759-6A51-4108-AA02-DFA0A04FC94B}">
-              <ma14:wrappingTextBoxFlag xmlns:ma14="http://schemas.microsoft.com/office/mac/drawingml/2011/main" xmlns="" val="0"/>
+              <ma14:wrappingTextBoxFlag xmlns="" xmlns:ma14="http://schemas.microsoft.com/office/mac/drawingml/2011/main" val="0"/>
             </a:ext>
           </a:extLst>
         </p:spPr>

</xml_diff>